<commit_message>
minor fixes in tokenization lecure
</commit_message>
<xml_diff>
--- a/lectures/06_tokenization/06_tokenization.pptx
+++ b/lectures/06_tokenization/06_tokenization.pptx
@@ -139,7 +139,7 @@
 <file path=ppt/revisionInfo.xml><?xml version="1.0" encoding="utf-8"?>
 <p1510:revInfo xmlns:a="http://schemas.openxmlformats.org/drawingml/2006/main" xmlns:r="http://schemas.openxmlformats.org/officeDocument/2006/relationships" xmlns:p1510="http://schemas.microsoft.com/office/powerpoint/2015/10/main">
   <p1510:revLst>
-    <p1510:client id="{816E74F5-4F20-CC32-B540-6E0770E01D49}" v="13" dt="2025-05-23T15:39:13.982"/>
+    <p1510:client id="{30246052-6994-8061-B4F9-4024BFE55008}" v="18" dt="2026-04-13T18:13:47.760"/>
   </p1510:revLst>
 </p1510:revInfo>
 </file>
@@ -178,7 +178,7 @@
           <a:p>
             <a:r>
               <a:rPr lang="en-US"/>
-              <a:t>Dr. Daniel Ruffinelli - FSS 2025</a:t>
+              <a:t>Dr. Daniel Ruffinelli - FSS 2026</a:t>
             </a:r>
             <a:endParaRPr/>
           </a:p>
@@ -382,7 +382,7 @@
           <a:p>
             <a:r>
               <a:rPr lang="en-US"/>
-              <a:t>Dr. Daniel Ruffinelli - FSS 2025</a:t>
+              <a:t>Dr. Daniel Ruffinelli - FSS 2026</a:t>
             </a:r>
             <a:endParaRPr/>
           </a:p>
@@ -662,7 +662,7 @@
           <a:p>
             <a:r>
               <a:rPr lang="en-US"/>
-              <a:t>Dr. Daniel Ruffinelli - FSS 2025</a:t>
+              <a:t>Dr. Daniel Ruffinelli - FSS 2026</a:t>
             </a:r>
             <a:endParaRPr/>
           </a:p>
@@ -1018,7 +1018,7 @@
           <a:p>
             <a:r>
               <a:rPr lang="en-US"/>
-              <a:t>Dr. Daniel Ruffinelli - FSS 2025</a:t>
+              <a:t>Dr. Daniel Ruffinelli - FSS 2026</a:t>
             </a:r>
             <a:endParaRPr/>
           </a:p>
@@ -1108,7 +1108,7 @@
           <a:p>
             <a:r>
               <a:rPr lang="en-US"/>
-              <a:t>Dr. Daniel Ruffinelli - FSS 2025</a:t>
+              <a:t>Dr. Daniel Ruffinelli - FSS 2026</a:t>
             </a:r>
             <a:endParaRPr/>
           </a:p>
@@ -1274,7 +1274,7 @@
           <a:p>
             <a:r>
               <a:rPr lang="en-US"/>
-              <a:t>Dr. Daniel Ruffinelli - FSS 2025</a:t>
+              <a:t>Dr. Daniel Ruffinelli - FSS 2026</a:t>
             </a:r>
             <a:endParaRPr/>
           </a:p>
@@ -1440,7 +1440,7 @@
           <a:p>
             <a:r>
               <a:rPr lang="en-US"/>
-              <a:t>Dr. Daniel Ruffinelli - FSS 2025</a:t>
+              <a:t>Dr. Daniel Ruffinelli - FSS 2026</a:t>
             </a:r>
             <a:endParaRPr/>
           </a:p>
@@ -1644,7 +1644,7 @@
           <a:p>
             <a:r>
               <a:rPr lang="en-US"/>
-              <a:t>Dr. Daniel Ruffinelli - FSS 2025</a:t>
+              <a:t>Dr. Daniel Ruffinelli - FSS 2026</a:t>
             </a:r>
             <a:endParaRPr/>
           </a:p>
@@ -1772,7 +1772,7 @@
           <a:p>
             <a:r>
               <a:rPr lang="en-US"/>
-              <a:t>Dr. Daniel Ruffinelli - FSS 2025</a:t>
+              <a:t>Dr. Daniel Ruffinelli - FSS 2026</a:t>
             </a:r>
             <a:endParaRPr/>
           </a:p>
@@ -1900,7 +1900,7 @@
           <a:p>
             <a:r>
               <a:rPr lang="en-US"/>
-              <a:t>Dr. Daniel Ruffinelli - FSS 2025</a:t>
+              <a:t>Dr. Daniel Ruffinelli - FSS 2026</a:t>
             </a:r>
             <a:endParaRPr/>
           </a:p>
@@ -2142,7 +2142,7 @@
           <a:p>
             <a:r>
               <a:rPr lang="en-US"/>
-              <a:t>Dr. Daniel Ruffinelli - FSS 2025</a:t>
+              <a:t>Dr. Daniel Ruffinelli - FSS 2026</a:t>
             </a:r>
             <a:endParaRPr/>
           </a:p>
@@ -2308,7 +2308,7 @@
           <a:p>
             <a:r>
               <a:rPr lang="en-US"/>
-              <a:t>Dr. Daniel Ruffinelli - FSS 2025</a:t>
+              <a:t>Dr. Daniel Ruffinelli - FSS 2026</a:t>
             </a:r>
             <a:endParaRPr/>
           </a:p>
@@ -2550,7 +2550,7 @@
           <a:p>
             <a:r>
               <a:rPr lang="en-US"/>
-              <a:t>Dr. Daniel Ruffinelli - FSS 2025</a:t>
+              <a:t>Dr. Daniel Ruffinelli - FSS 2026</a:t>
             </a:r>
             <a:endParaRPr/>
           </a:p>
@@ -2792,7 +2792,7 @@
           <a:p>
             <a:r>
               <a:rPr lang="en-US"/>
-              <a:t>Dr. Daniel Ruffinelli - FSS 2025</a:t>
+              <a:t>Dr. Daniel Ruffinelli - FSS 2026</a:t>
             </a:r>
             <a:endParaRPr/>
           </a:p>
@@ -2996,7 +2996,7 @@
           <a:p>
             <a:r>
               <a:rPr lang="en-US"/>
-              <a:t>Dr. Daniel Ruffinelli - FSS 2025</a:t>
+              <a:t>Dr. Daniel Ruffinelli - FSS 2026</a:t>
             </a:r>
             <a:endParaRPr/>
           </a:p>
@@ -3276,7 +3276,7 @@
           <a:p>
             <a:r>
               <a:rPr lang="en-US"/>
-              <a:t>Dr. Daniel Ruffinelli - FSS 2025</a:t>
+              <a:t>Dr. Daniel Ruffinelli - FSS 2026</a:t>
             </a:r>
             <a:endParaRPr/>
           </a:p>
@@ -3632,7 +3632,7 @@
           <a:p>
             <a:r>
               <a:rPr lang="en-US"/>
-              <a:t>Dr. Daniel Ruffinelli - FSS 2025</a:t>
+              <a:t>Dr. Daniel Ruffinelli - FSS 2026</a:t>
             </a:r>
             <a:endParaRPr/>
           </a:p>
@@ -3798,7 +3798,7 @@
           <a:p>
             <a:r>
               <a:rPr lang="en-US"/>
-              <a:t>Dr. Daniel Ruffinelli - FSS 2025</a:t>
+              <a:t>Dr. Daniel Ruffinelli - FSS 2026</a:t>
             </a:r>
             <a:endParaRPr/>
           </a:p>
@@ -4002,7 +4002,7 @@
           <a:p>
             <a:r>
               <a:rPr lang="en-US"/>
-              <a:t>Dr. Daniel Ruffinelli - FSS 2025</a:t>
+              <a:t>Dr. Daniel Ruffinelli - FSS 2026</a:t>
             </a:r>
             <a:endParaRPr/>
           </a:p>
@@ -4130,7 +4130,7 @@
           <a:p>
             <a:r>
               <a:rPr lang="en-US"/>
-              <a:t>Dr. Daniel Ruffinelli - FSS 2025</a:t>
+              <a:t>Dr. Daniel Ruffinelli - FSS 2026</a:t>
             </a:r>
             <a:endParaRPr/>
           </a:p>
@@ -4258,7 +4258,7 @@
           <a:p>
             <a:r>
               <a:rPr lang="en-US"/>
-              <a:t>Dr. Daniel Ruffinelli - FSS 2025</a:t>
+              <a:t>Dr. Daniel Ruffinelli - FSS 2026</a:t>
             </a:r>
             <a:endParaRPr/>
           </a:p>
@@ -4500,7 +4500,7 @@
           <a:p>
             <a:r>
               <a:rPr lang="en-US"/>
-              <a:t>Dr. Daniel Ruffinelli - FSS 2025</a:t>
+              <a:t>Dr. Daniel Ruffinelli - FSS 2026</a:t>
             </a:r>
             <a:endParaRPr/>
           </a:p>
@@ -4742,7 +4742,7 @@
           <a:p>
             <a:r>
               <a:rPr lang="en-US"/>
-              <a:t>Dr. Daniel Ruffinelli - FSS 2025</a:t>
+              <a:t>Dr. Daniel Ruffinelli - FSS 2026</a:t>
             </a:r>
             <a:endParaRPr/>
           </a:p>
@@ -4984,7 +4984,7 @@
           <a:p>
             <a:r>
               <a:rPr lang="en-US"/>
-              <a:t>Dr. Daniel Ruffinelli - FSS 2025</a:t>
+              <a:t>Dr. Daniel Ruffinelli - FSS 2026</a:t>
             </a:r>
             <a:endParaRPr/>
           </a:p>
@@ -5259,7 +5259,7 @@
                 </a:solidFill>
                 <a:latin typeface="Calibri"/>
               </a:rPr>
-              <a:t>Dr. Daniel Ruffinelli - FSS 2025</a:t>
+              <a:t>Dr. Daniel Ruffinelli - FSS 2026</a:t>
             </a:r>
             <a:endParaRPr lang="en-US" sz="1200" b="0" strike="noStrike" spc="-1">
               <a:latin typeface="Times New Roman"/>
@@ -6208,7 +6208,7 @@
                 </a:solidFill>
                 <a:latin typeface="Calibri"/>
               </a:rPr>
-              <a:t>Dr. Daniel Ruffinelli - FSS 2025</a:t>
+              <a:t>Dr. Daniel Ruffinelli - FSS 2026</a:t>
             </a:r>
             <a:endParaRPr lang="en-US" sz="1200" b="0" strike="noStrike" spc="-1">
               <a:latin typeface="Times New Roman"/>
@@ -6757,7 +6757,7 @@
                 </a:solidFill>
                 <a:latin typeface="Calibri"/>
               </a:rPr>
-              <a:t>Dr. Daniel Ruffinelli - FSS 2025</a:t>
+              <a:t>Dr. Daniel Ruffinelli - FSS 2026</a:t>
             </a:r>
             <a:endParaRPr lang="en-US" sz="1200" b="0" strike="noStrike" spc="-1">
               <a:latin typeface="Times New Roman"/>
@@ -7123,7 +7123,7 @@
                 </a:solidFill>
                 <a:latin typeface="Calibri"/>
               </a:rPr>
-              <a:t>Dr. Daniel Ruffinelli - FSS 2025</a:t>
+              <a:t>Dr. Daniel Ruffinelli - FSS 2026</a:t>
             </a:r>
             <a:endParaRPr lang="en-US" sz="1200" b="0" strike="noStrike" spc="-1">
               <a:latin typeface="Times New Roman"/>
@@ -9745,7 +9745,7 @@
                 </a:solidFill>
                 <a:latin typeface="Calibri"/>
               </a:rPr>
-              <a:t>Dr. Daniel Ruffinelli - FSS 2025</a:t>
+              <a:t>Dr. Daniel Ruffinelli - FSS 2026</a:t>
             </a:r>
             <a:endParaRPr lang="en-US" sz="1200" b="0" strike="noStrike" spc="-1">
               <a:latin typeface="Times New Roman"/>
@@ -10056,7 +10056,7 @@
                 </a:solidFill>
                 <a:latin typeface="Calibri"/>
               </a:rPr>
-              <a:t>Dr. Daniel Ruffinelli - FSS 2025</a:t>
+              <a:t>Dr. Daniel Ruffinelli - FSS 2026</a:t>
             </a:r>
             <a:endParaRPr lang="en-US" sz="1200" b="0" strike="noStrike" spc="-1">
               <a:latin typeface="Times New Roman"/>
@@ -11537,7 +11537,7 @@
                 </a:solidFill>
                 <a:latin typeface="Calibri"/>
               </a:rPr>
-              <a:t>Dr. Daniel Ruffinelli - FSS 2025</a:t>
+              <a:t>Dr. Daniel Ruffinelli - FSS 2026</a:t>
             </a:r>
             <a:endParaRPr lang="en-US" sz="1200" b="0" strike="noStrike" spc="-1">
               <a:latin typeface="Times New Roman"/>
@@ -13039,7 +13039,7 @@
                 </a:solidFill>
                 <a:latin typeface="Calibri"/>
               </a:rPr>
-              <a:t>Dr. Daniel Ruffinelli - FSS 2025</a:t>
+              <a:t>Dr. Daniel Ruffinelli - FSS 2026</a:t>
             </a:r>
             <a:endParaRPr lang="en-US" sz="1200" b="0" strike="noStrike" spc="-1">
               <a:latin typeface="Times New Roman"/>
@@ -14391,7 +14391,7 @@
                 </a:solidFill>
                 <a:latin typeface="Calibri"/>
               </a:rPr>
-              <a:t>Dr. Daniel Ruffinelli - FSS 2025</a:t>
+              <a:t>Dr. Daniel Ruffinelli - FSS 2026</a:t>
             </a:r>
             <a:endParaRPr lang="en-US" sz="1200" b="0" strike="noStrike" spc="-1">
               <a:latin typeface="Times New Roman"/>
@@ -15678,7 +15678,7 @@
                 </a:solidFill>
                 <a:latin typeface="Calibri"/>
               </a:rPr>
-              <a:t>Dr. Daniel Ruffinelli - FSS 2025</a:t>
+              <a:t>Dr. Daniel Ruffinelli - FSS 2026</a:t>
             </a:r>
             <a:endParaRPr lang="en-US" sz="1200" b="0" strike="noStrike" spc="-1">
               <a:latin typeface="Times New Roman"/>
@@ -17648,7 +17648,7 @@
                 </a:solidFill>
                 <a:latin typeface="Calibri"/>
               </a:rPr>
-              <a:t>Dr. Daniel Ruffinelli - FSS 2025</a:t>
+              <a:t>Dr. Daniel Ruffinelli - FSS 2026</a:t>
             </a:r>
             <a:endParaRPr lang="en-US" sz="1200" b="0" strike="noStrike" spc="-1">
               <a:latin typeface="Times New Roman"/>
@@ -19152,7 +19152,7 @@
                 </a:solidFill>
                 <a:latin typeface="Calibri"/>
               </a:rPr>
-              <a:t>Dr. Daniel Ruffinelli - FSS 2025</a:t>
+              <a:t>Dr. Daniel Ruffinelli - FSS 2026</a:t>
             </a:r>
             <a:endParaRPr lang="en-US" sz="1200" b="0" strike="noStrike" spc="-1">
               <a:latin typeface="Times New Roman"/>
@@ -20260,7 +20260,7 @@
                 </a:solidFill>
                 <a:latin typeface="Calibri"/>
               </a:rPr>
-              <a:t>Dr. Daniel Ruffinelli - FSS 2025</a:t>
+              <a:t>Dr. Daniel Ruffinelli - FSS 2026</a:t>
             </a:r>
             <a:endParaRPr lang="en-US" sz="1200" b="0" strike="noStrike" spc="-1">
               <a:latin typeface="Times New Roman"/>
@@ -21279,7 +21279,7 @@
                 </a:solidFill>
                 <a:latin typeface="Calibri"/>
               </a:rPr>
-              <a:t>Dr. Daniel Ruffinelli - FSS 2025</a:t>
+              <a:t>Dr. Daniel Ruffinelli - FSS 2026</a:t>
             </a:r>
             <a:endParaRPr lang="en-US" sz="1200" b="0" strike="noStrike" spc="-1">
               <a:latin typeface="Times New Roman"/>
@@ -23353,7 +23353,7 @@
                 </a:solidFill>
                 <a:latin typeface="Calibri"/>
               </a:rPr>
-              <a:t>Dr. Daniel Ruffinelli - FSS 2025</a:t>
+              <a:t>Dr. Daniel Ruffinelli - FSS 2026</a:t>
             </a:r>
             <a:endParaRPr lang="en-US" sz="1200" b="0" strike="noStrike" spc="-1">
               <a:latin typeface="Times New Roman"/>
@@ -24762,7 +24762,7 @@
                 </a:solidFill>
                 <a:latin typeface="Calibri"/>
               </a:rPr>
-              <a:t>Dr. Daniel Ruffinelli - FSS 2025</a:t>
+              <a:t>Dr. Daniel Ruffinelli - FSS 2026</a:t>
             </a:r>
             <a:endParaRPr lang="en-US" sz="1200" b="0" strike="noStrike" spc="-1">
               <a:latin typeface="Times New Roman"/>
@@ -25552,7 +25552,7 @@
                 </a:solidFill>
                 <a:latin typeface="Calibri"/>
               </a:rPr>
-              <a:t>Dr. Daniel Ruffinelli - FSS 2025</a:t>
+              <a:t>Dr. Daniel Ruffinelli - FSS 2026</a:t>
             </a:r>
             <a:endParaRPr lang="en-US" sz="1200" b="0" strike="noStrike" spc="-1">
               <a:latin typeface="Times New Roman"/>
@@ -26882,7 +26882,7 @@
                 </a:solidFill>
                 <a:latin typeface="Calibri"/>
               </a:rPr>
-              <a:t>Dr. Daniel Ruffinelli - FSS 2025</a:t>
+              <a:t>Dr. Daniel Ruffinelli - FSS 2026</a:t>
             </a:r>
             <a:endParaRPr lang="en-US" sz="1200" b="0" strike="noStrike" spc="-1">
               <a:latin typeface="Times New Roman"/>
@@ -26958,7 +26958,7 @@
               </a:rPr>
               <a:t>:</a:t>
             </a:r>
-            <a:endParaRPr lang="en-US" sz="2200" spc="-1" dirty="0">
+            <a:endParaRPr lang="en-US" sz="2200" spc="-1">
               <a:solidFill>
                 <a:srgbClr val="000000"/>
               </a:solidFill>
@@ -26998,7 +26998,7 @@
               </a:rPr>
               <a:t>often helps LM performance</a:t>
             </a:r>
-            <a:endParaRPr lang="en-US" sz="1800" b="1" spc="-1" dirty="0">
+            <a:endParaRPr lang="en-US" sz="1800" b="1" spc="-1">
               <a:solidFill>
                 <a:srgbClr val="000000"/>
               </a:solidFill>
@@ -27053,9 +27053,9 @@
               <a:solidFill>
                 <a:srgbClr val="003056"/>
               </a:solidFill>
-              <a:latin typeface="DejaVu Sans"/>
+              <a:latin typeface="Calibri"/>
               <a:ea typeface="Calibri"/>
-              <a:cs typeface="Arial"/>
+              <a:cs typeface="Calibri"/>
             </a:endParaRPr>
           </a:p>
           <a:p>
@@ -27095,19 +27095,9 @@
                 </a:solidFill>
                 <a:latin typeface="Calibri"/>
                 <a:ea typeface="Calibri"/>
-                <a:cs typeface="Arial"/>
-              </a:rPr>
-              <a:t>Character-level</a:t>
-            </a:r>
-            <a:r>
-              <a:rPr lang="en-US" sz="2000" b="1" spc="-1" dirty="0">
-                <a:solidFill>
-                  <a:srgbClr val="003056"/>
-                </a:solidFill>
-                <a:latin typeface="Calibri"/>
-                <a:cs typeface="Arial"/>
-              </a:rPr>
-              <a:t> tokens</a:t>
+                <a:cs typeface="Calibri"/>
+              </a:rPr>
+              <a:t>Character-level tokens</a:t>
             </a:r>
             <a:r>
               <a:rPr lang="en-US" sz="2000" spc="-1" dirty="0">
@@ -27115,7 +27105,8 @@
                   <a:srgbClr val="003056"/>
                 </a:solidFill>
                 <a:latin typeface="Calibri"/>
-                <a:cs typeface="Arial"/>
+                <a:ea typeface="Calibri"/>
+                <a:cs typeface="Calibri"/>
               </a:rPr>
               <a:t>:</a:t>
             </a:r>
@@ -27141,41 +27132,9 @@
                 <a:ea typeface="Calibri"/>
                 <a:cs typeface="Calibri"/>
               </a:rPr>
-              <a:t>Smaller vocabulary but p</a:t>
-            </a:r>
-            <a:r>
-              <a:rPr lang="en-US" sz="1800" spc="-1" dirty="0">
-                <a:solidFill>
-                  <a:srgbClr val="003056"/>
-                </a:solidFill>
-                <a:latin typeface="Calibri"/>
-                <a:cs typeface="Arial"/>
-              </a:rPr>
-              <a:t>otentially meaningless representations, </a:t>
-            </a:r>
-            <a:r>
-              <a:rPr lang="en-US" sz="1800" spc="-1" dirty="0">
-                <a:solidFill>
-                  <a:srgbClr val="003056"/>
-                </a:solidFill>
-                <a:latin typeface="DejaVu Sans"/>
-                <a:ea typeface="Calibri"/>
-                <a:cs typeface="Arial"/>
-              </a:rPr>
-              <a:t>o</a:t>
-            </a:r>
-            <a:r>
-              <a:rPr lang="en-US" sz="1800" spc="-1" dirty="0">
-                <a:solidFill>
-                  <a:srgbClr val="003056"/>
-                </a:solidFill>
-                <a:latin typeface="Calibri"/>
-                <a:ea typeface="Calibri"/>
-                <a:cs typeface="Calibri"/>
-              </a:rPr>
-              <a:t>ften associated with lower LM performance</a:t>
-            </a:r>
-            <a:endParaRPr lang="en-US" sz="1800" spc="-1" dirty="0">
+              <a:t>Smaller vocabulary but potentially meaningless representations, often associated with lower LM performance</a:t>
+            </a:r>
+            <a:endParaRPr lang="en-US" sz="1800" spc="-1">
               <a:solidFill>
                 <a:srgbClr val="000000"/>
               </a:solidFill>
@@ -27202,30 +27161,10 @@
                   <a:srgbClr val="003056"/>
                 </a:solidFill>
                 <a:latin typeface="Calibri"/>
-                <a:cs typeface="Arial"/>
-              </a:rPr>
-              <a:t>May require </a:t>
-            </a:r>
-            <a:r>
-              <a:rPr lang="en-US" sz="1800" b="1" spc="-1" dirty="0">
-                <a:solidFill>
-                  <a:srgbClr val="003056"/>
-                </a:solidFill>
-                <a:latin typeface="Calibri"/>
                 <a:ea typeface="Calibri"/>
                 <a:cs typeface="Calibri"/>
               </a:rPr>
-              <a:t>higher capacity </a:t>
-            </a:r>
-            <a:r>
-              <a:rPr lang="en-US" sz="1800" b="1" spc="-1" dirty="0">
-                <a:solidFill>
-                  <a:srgbClr val="003056"/>
-                </a:solidFill>
-                <a:latin typeface="Calibri"/>
-                <a:cs typeface="Arial"/>
-              </a:rPr>
-              <a:t>models to learn to use representations well </a:t>
+              <a:t>May require higher capacity models to learn to use representations well </a:t>
             </a:r>
           </a:p>
           <a:p>
@@ -27246,7 +27185,8 @@
                   <a:srgbClr val="003056"/>
                 </a:solidFill>
                 <a:latin typeface="Calibri"/>
-                <a:cs typeface="Arial"/>
+                <a:ea typeface="Calibri"/>
+                <a:cs typeface="Calibri"/>
               </a:rPr>
               <a:t>BPE-like processes require more merges/data (i.e. larger vocabulary, more parameters) to get to meaningful </a:t>
             </a:r>
@@ -27256,7 +27196,8 @@
                   <a:srgbClr val="003056"/>
                 </a:solidFill>
                 <a:latin typeface="Calibri"/>
-                <a:cs typeface="Arial"/>
+                <a:ea typeface="Calibri"/>
+                <a:cs typeface="Calibri"/>
               </a:rPr>
               <a:t>subwors</a:t>
             </a:r>
@@ -27266,7 +27207,8 @@
                   <a:srgbClr val="003056"/>
                 </a:solidFill>
                 <a:latin typeface="Calibri"/>
-                <a:cs typeface="Arial"/>
+                <a:ea typeface="Calibri"/>
+                <a:cs typeface="Calibri"/>
               </a:rPr>
               <a:t>/words</a:t>
             </a:r>
@@ -27309,7 +27251,8 @@
                 <a:srgbClr val="003056"/>
               </a:solidFill>
               <a:latin typeface="Calibri"/>
-              <a:cs typeface="Arial"/>
+              <a:ea typeface="Calibri"/>
+              <a:cs typeface="Calibri"/>
             </a:endParaRPr>
           </a:p>
           <a:p>
@@ -27329,7 +27272,8 @@
                 <a:srgbClr val="003056"/>
               </a:solidFill>
               <a:latin typeface="Calibri"/>
-              <a:cs typeface="Arial"/>
+              <a:ea typeface="Calibri"/>
+              <a:cs typeface="Calibri"/>
             </a:endParaRPr>
           </a:p>
         </p:txBody>
@@ -28064,7 +28008,7 @@
                 </a:solidFill>
                 <a:latin typeface="Calibri"/>
               </a:rPr>
-              <a:t>Dr. Daniel Ruffinelli - FSS 2025</a:t>
+              <a:t>Dr. Daniel Ruffinelli - FSS 2026</a:t>
             </a:r>
             <a:endParaRPr lang="en-US" sz="1200" b="0" strike="noStrike" spc="-1">
               <a:latin typeface="Times New Roman"/>
@@ -29392,7 +29336,7 @@
                 </a:solidFill>
                 <a:latin typeface="Calibri"/>
               </a:rPr>
-              <a:t>Dr. Daniel Ruffinelli - FSS 2025</a:t>
+              <a:t>Dr. Daniel Ruffinelli - FSS 2026</a:t>
             </a:r>
             <a:endParaRPr lang="en-US" sz="1200" b="0" strike="noStrike" spc="-1">
               <a:latin typeface="Times New Roman"/>
@@ -29652,14 +29596,14 @@
               </a:buClr>
             </a:pPr>
             <a:r>
-              <a:rPr lang="en-US" sz="1800" spc="-1" dirty="0">
+              <a:rPr lang="en-US" sz="1800" spc="-1">
                 <a:solidFill>
                   <a:srgbClr val="003056"/>
                 </a:solidFill>
                 <a:latin typeface="Calibri"/>
                 <a:cs typeface="Arial"/>
               </a:rPr>
-              <a:t>Thus, such characters typically use single byte: </a:t>
+              <a:t>Thus, following characters typically use single byte: </a:t>
             </a:r>
             <a:r>
               <a:rPr lang="en-US" sz="1800" i="1" spc="-1" dirty="0">
@@ -29788,7 +29732,7 @@
               <a:t> symbol </a:t>
             </a:r>
             <a:r>
-              <a:rPr lang="ja-JP" altLang="en-US" sz="1800" spc="-1">
+              <a:rPr lang="ja-JP" altLang="en-US" sz="1800" spc="-1" dirty="0">
                 <a:solidFill>
                   <a:srgbClr val="003056"/>
                 </a:solidFill>
@@ -29972,7 +29916,7 @@
               <a:t>K</a:t>
             </a:r>
             <a:r>
-              <a:rPr lang="en-US" sz="1800" spc="-1" dirty="0">
+              <a:rPr lang="en-US" sz="1800" spc="-1">
                 <a:solidFill>
                   <a:srgbClr val="003056"/>
                 </a:solidFill>
@@ -30925,7 +30869,7 @@
                 </a:solidFill>
                 <a:latin typeface="Calibri"/>
               </a:rPr>
-              <a:t>Dr. Daniel Ruffinelli - FSS 2025</a:t>
+              <a:t>Dr. Daniel Ruffinelli - FSS 2026</a:t>
             </a:r>
             <a:endParaRPr lang="en-US" sz="1200" b="0" strike="noStrike" spc="-1">
               <a:latin typeface="Times New Roman"/>
@@ -31899,7 +31843,7 @@
                 </a:solidFill>
                 <a:latin typeface="Calibri"/>
               </a:rPr>
-              <a:t>Dr. Daniel Ruffinelli - FSS 2025</a:t>
+              <a:t>Dr. Daniel Ruffinelli - FSS 2026</a:t>
             </a:r>
             <a:endParaRPr lang="en-US" sz="1200" b="0" strike="noStrike" spc="-1">
               <a:latin typeface="Times New Roman"/>
@@ -33000,7 +32944,7 @@
                 </a:solidFill>
                 <a:latin typeface="Calibri"/>
               </a:rPr>
-              <a:t>Dr. Daniel Ruffinelli - FSS 2025</a:t>
+              <a:t>Dr. Daniel Ruffinelli - FSS 2026</a:t>
             </a:r>
             <a:endParaRPr lang="en-US" sz="1200" b="0" strike="noStrike" spc="-1">
               <a:latin typeface="Times New Roman"/>
@@ -34286,7 +34230,7 @@
                 </a:solidFill>
                 <a:latin typeface="Calibri"/>
               </a:rPr>
-              <a:t>Dr. Daniel Ruffinelli - FSS 2025</a:t>
+              <a:t>Dr. Daniel Ruffinelli - FSS 2026</a:t>
             </a:r>
             <a:endParaRPr lang="en-US" sz="1200" b="0" strike="noStrike" spc="-1">
               <a:latin typeface="Times New Roman"/>
@@ -35126,7 +35070,7 @@
                 </a:solidFill>
                 <a:latin typeface="Calibri"/>
               </a:rPr>
-              <a:t>Dr. Daniel Ruffinelli - FSS 2025</a:t>
+              <a:t>Dr. Daniel Ruffinelli - FSS 2026</a:t>
             </a:r>
             <a:endParaRPr lang="en-US" sz="1200" b="0" strike="noStrike" spc="-1">
               <a:latin typeface="Times New Roman"/>
@@ -36586,7 +36530,7 @@
                 </a:solidFill>
                 <a:latin typeface="Calibri"/>
               </a:rPr>
-              <a:t>Dr. Daniel Ruffinelli - FSS 2025</a:t>
+              <a:t>Dr. Daniel Ruffinelli - FSS 2026</a:t>
             </a:r>
             <a:endParaRPr lang="en-US" sz="1200" b="0" strike="noStrike" spc="-1">
               <a:latin typeface="Times New Roman"/>
@@ -37658,7 +37602,7 @@
                 </a:solidFill>
                 <a:latin typeface="Calibri"/>
               </a:rPr>
-              <a:t>Dr. Daniel Ruffinelli - FSS 2025</a:t>
+              <a:t>Dr. Daniel Ruffinelli - FSS 2026</a:t>
             </a:r>
             <a:endParaRPr lang="en-US" sz="1200" b="0" strike="noStrike" spc="-1">
               <a:latin typeface="Times New Roman"/>
@@ -38195,7 +38139,7 @@
                 </a:solidFill>
                 <a:latin typeface="Calibri"/>
               </a:rPr>
-              <a:t>Dr. Daniel Ruffinelli - FSS 2025</a:t>
+              <a:t>Dr. Daniel Ruffinelli - FSS 2026</a:t>
             </a:r>
             <a:endParaRPr lang="en-US" sz="1200" b="0" strike="noStrike" spc="-1">
               <a:latin typeface="Times New Roman"/>
@@ -38535,7 +38479,7 @@
                 </a:solidFill>
                 <a:latin typeface="Calibri"/>
               </a:rPr>
-              <a:t>Dr. Daniel Ruffinelli - FSS 2025</a:t>
+              <a:t>Dr. Daniel Ruffinelli - FSS 2026</a:t>
             </a:r>
             <a:endParaRPr lang="en-US" sz="1200" b="0" strike="noStrike" spc="-1">
               <a:latin typeface="Times New Roman"/>
@@ -38589,6 +38533,8 @@
                   <a:srgbClr val="003056"/>
                 </a:solidFill>
                 <a:latin typeface="Calibri"/>
+                <a:ea typeface="Calibri"/>
+                <a:cs typeface="Calibri"/>
               </a:rPr>
               <a:t>Tokens </a:t>
             </a:r>
@@ -38598,6 +38544,8 @@
                   <a:srgbClr val="003056"/>
                 </a:solidFill>
                 <a:latin typeface="Calibri"/>
+                <a:ea typeface="Calibri"/>
+                <a:cs typeface="Calibri"/>
               </a:rPr>
               <a:t>are the </a:t>
             </a:r>
@@ -38607,6 +38555,8 @@
                   <a:srgbClr val="003056"/>
                 </a:solidFill>
                 <a:latin typeface="Calibri"/>
+                <a:ea typeface="Calibri"/>
+                <a:cs typeface="Calibri"/>
               </a:rPr>
               <a:t>atomic units seen/handled by LMs</a:t>
             </a:r>
@@ -38616,10 +38566,16 @@
                   <a:srgbClr val="003056"/>
                 </a:solidFill>
                 <a:latin typeface="Calibri"/>
+                <a:ea typeface="Calibri"/>
+                <a:cs typeface="Calibri"/>
               </a:rPr>
               <a:t>.</a:t>
             </a:r>
-            <a:endParaRPr lang="en-US" dirty="0"/>
+            <a:endParaRPr lang="en-US">
+              <a:latin typeface="Calibri"/>
+              <a:ea typeface="Calibri"/>
+              <a:cs typeface="Calibri"/>
+            </a:endParaRPr>
           </a:p>
           <a:p>
             <a:pPr lvl="1">
@@ -38639,6 +38595,7 @@
                   <a:srgbClr val="003056"/>
                 </a:solidFill>
                 <a:latin typeface="Calibri"/>
+                <a:ea typeface="Calibri"/>
                 <a:cs typeface="Calibri"/>
               </a:rPr>
               <a:t>Set of tokens known to LM: </a:t>
@@ -38649,6 +38606,7 @@
                   <a:srgbClr val="003056"/>
                 </a:solidFill>
                 <a:latin typeface="Calibri"/>
+                <a:ea typeface="Calibri"/>
                 <a:cs typeface="Calibri"/>
               </a:rPr>
               <a:t>vocabulary</a:t>
@@ -38658,6 +38616,8 @@
                 <a:srgbClr val="003056"/>
               </a:solidFill>
               <a:latin typeface="Calibri"/>
+              <a:ea typeface="Calibri"/>
+              <a:cs typeface="Calibri"/>
             </a:endParaRPr>
           </a:p>
           <a:p>
@@ -38679,6 +38639,7 @@
                   <a:srgbClr val="003056"/>
                 </a:solidFill>
                 <a:latin typeface="Calibri"/>
+                <a:ea typeface="Calibri"/>
                 <a:cs typeface="Calibri"/>
               </a:rPr>
               <a:t>Each token </a:t>
@@ -38689,6 +38650,7 @@
                   <a:srgbClr val="003056"/>
                 </a:solidFill>
                 <a:latin typeface="Calibri"/>
+                <a:ea typeface="Calibri"/>
                 <a:cs typeface="Calibri"/>
               </a:rPr>
               <a:t>in vocabulary </a:t>
@@ -38699,6 +38661,7 @@
                   <a:srgbClr val="003056"/>
                 </a:solidFill>
                 <a:latin typeface="Calibri"/>
+                <a:ea typeface="Calibri"/>
                 <a:cs typeface="Calibri"/>
               </a:rPr>
               <a:t>mapped to representation vector </a:t>
@@ -38709,6 +38672,7 @@
                   <a:srgbClr val="003056"/>
                 </a:solidFill>
                 <a:latin typeface="Calibri"/>
+                <a:ea typeface="Calibri"/>
                 <a:cs typeface="Calibri"/>
               </a:rPr>
               <a:t>of size </a:t>
@@ -38719,15 +38683,17 @@
                   <a:srgbClr val="003056"/>
                 </a:solidFill>
                 <a:latin typeface="Calibri"/>
+                <a:ea typeface="Calibri"/>
                 <a:cs typeface="Calibri"/>
               </a:rPr>
               <a:t>d</a:t>
             </a:r>
-            <a:endParaRPr lang="en-US" sz="1800" spc="-1" dirty="0">
+            <a:endParaRPr lang="en-US" sz="1800" spc="-1">
               <a:solidFill>
                 <a:srgbClr val="000000"/>
               </a:solidFill>
               <a:latin typeface="Calibri"/>
+              <a:ea typeface="Calibri"/>
               <a:cs typeface="Calibri"/>
             </a:endParaRPr>
           </a:p>
@@ -38747,15 +38713,17 @@
                   <a:srgbClr val="003056"/>
                 </a:solidFill>
                 <a:latin typeface="Calibri"/>
+                <a:ea typeface="Calibri"/>
                 <a:cs typeface="Calibri"/>
               </a:rPr>
               <a:t>I.e. the typical (static) embedding table/matrix, impacts model size/costs</a:t>
             </a:r>
-            <a:endParaRPr lang="en-US" sz="1800" spc="-1" dirty="0">
+            <a:endParaRPr lang="en-US" sz="1800" spc="-1">
               <a:solidFill>
                 <a:srgbClr val="000000"/>
               </a:solidFill>
               <a:latin typeface="Calibri"/>
+              <a:ea typeface="Calibri"/>
               <a:cs typeface="Calibri"/>
             </a:endParaRPr>
           </a:p>
@@ -38779,6 +38747,8 @@
                   <a:srgbClr val="003056"/>
                 </a:solidFill>
                 <a:latin typeface="Calibri"/>
+                <a:ea typeface="Calibri"/>
+                <a:cs typeface="Calibri"/>
               </a:rPr>
               <a:t>Input sequences </a:t>
             </a:r>
@@ -38788,6 +38758,8 @@
                   <a:srgbClr val="003056"/>
                 </a:solidFill>
                 <a:latin typeface="Calibri"/>
+                <a:ea typeface="Calibri"/>
+                <a:cs typeface="Calibri"/>
               </a:rPr>
               <a:t>broken into finite sequence of known tokens</a:t>
             </a:r>
@@ -38812,6 +38784,8 @@
                   <a:srgbClr val="003056"/>
                 </a:solidFill>
                 <a:latin typeface="Calibri"/>
+                <a:ea typeface="Calibri"/>
+                <a:cs typeface="Calibri"/>
               </a:rPr>
               <a:t>E.g. </a:t>
             </a:r>
@@ -38821,6 +38795,7 @@
                   <a:srgbClr val="003056"/>
                 </a:solidFill>
                 <a:latin typeface="Calibri"/>
+                <a:ea typeface="Calibri"/>
                 <a:cs typeface="Calibri"/>
               </a:rPr>
               <a:t>Token</a:t>
@@ -38831,6 +38806,7 @@
                   <a:srgbClr val="003056"/>
                 </a:solidFill>
                 <a:latin typeface="Calibri"/>
+                <a:ea typeface="Calibri"/>
                 <a:cs typeface="Calibri"/>
               </a:rPr>
               <a:t> </a:t>
@@ -38841,6 +38817,7 @@
                   <a:srgbClr val="003056"/>
                 </a:solidFill>
                 <a:latin typeface="Calibri"/>
+                <a:ea typeface="Calibri"/>
                 <a:cs typeface="Calibri"/>
               </a:rPr>
               <a:t>ization</a:t>
@@ -38851,6 +38828,7 @@
                   <a:srgbClr val="003056"/>
                 </a:solidFill>
                 <a:latin typeface="Calibri"/>
+                <a:ea typeface="Calibri"/>
                 <a:cs typeface="Calibri"/>
               </a:rPr>
               <a:t> </a:t>
@@ -38860,10 +38838,22 @@
                 <a:solidFill>
                   <a:srgbClr val="003056"/>
                 </a:solidFill>
-                <a:latin typeface="Arial"/>
-                <a:cs typeface="Arial"/>
-              </a:rPr>
-              <a:t>⋅</a:t>
+                <a:latin typeface="Calibri"/>
+                <a:ea typeface="Calibri"/>
+                <a:cs typeface="Calibri"/>
+              </a:rPr>
+              <a:t>⋅won</a:t>
+            </a:r>
+            <a:r>
+              <a:rPr lang="en-US" sz="1800" spc="-1" dirty="0">
+                <a:solidFill>
+                  <a:srgbClr val="003056"/>
+                </a:solidFill>
+                <a:latin typeface="Calibri"/>
+                <a:ea typeface="Calibri"/>
+                <a:cs typeface="Calibri"/>
+              </a:rPr>
+              <a:t> </a:t>
             </a:r>
             <a:r>
               <a:rPr lang="en-US" sz="1800" u="sng" spc="-1" dirty="0">
@@ -38871,9 +38861,10 @@
                   <a:srgbClr val="003056"/>
                 </a:solidFill>
                 <a:latin typeface="Calibri"/>
+                <a:ea typeface="Calibri"/>
                 <a:cs typeface="Calibri"/>
               </a:rPr>
-              <a:t>won</a:t>
+              <a:t>'t</a:t>
             </a:r>
             <a:r>
               <a:rPr lang="en-US" sz="1800" spc="-1" dirty="0">
@@ -38881,6 +38872,7 @@
                   <a:srgbClr val="003056"/>
                 </a:solidFill>
                 <a:latin typeface="Calibri"/>
+                <a:ea typeface="Calibri"/>
                 <a:cs typeface="Calibri"/>
               </a:rPr>
               <a:t> </a:t>
@@ -38891,9 +38883,10 @@
                   <a:srgbClr val="003056"/>
                 </a:solidFill>
                 <a:latin typeface="Calibri"/>
+                <a:ea typeface="Calibri"/>
                 <a:cs typeface="Calibri"/>
               </a:rPr>
-              <a:t>'t</a:t>
+              <a:t>⋅be</a:t>
             </a:r>
             <a:r>
               <a:rPr lang="en-US" sz="1800" spc="-1" dirty="0">
@@ -38901,6 +38894,7 @@
                   <a:srgbClr val="003056"/>
                 </a:solidFill>
                 <a:latin typeface="Calibri"/>
+                <a:ea typeface="Calibri"/>
                 <a:cs typeface="Calibri"/>
               </a:rPr>
               <a:t> </a:t>
@@ -38910,10 +38904,22 @@
                 <a:solidFill>
                   <a:srgbClr val="003056"/>
                 </a:solidFill>
-                <a:latin typeface="Arial"/>
-                <a:cs typeface="Arial"/>
-              </a:rPr>
-              <a:t>⋅</a:t>
+                <a:latin typeface="Calibri"/>
+                <a:ea typeface="Calibri"/>
+                <a:cs typeface="Calibri"/>
+              </a:rPr>
+              <a:t>⋅neglected</a:t>
+            </a:r>
+            <a:r>
+              <a:rPr lang="en-US" sz="1800" spc="-1" dirty="0">
+                <a:solidFill>
+                  <a:srgbClr val="003056"/>
+                </a:solidFill>
+                <a:latin typeface="Calibri"/>
+                <a:ea typeface="Calibri"/>
+                <a:cs typeface="Calibri"/>
+              </a:rPr>
+              <a:t> </a:t>
             </a:r>
             <a:r>
               <a:rPr lang="en-US" sz="1800" u="sng" spc="-1" dirty="0">
@@ -38921,71 +38927,16 @@
                   <a:srgbClr val="003056"/>
                 </a:solidFill>
                 <a:latin typeface="Calibri"/>
+                <a:ea typeface="Calibri"/>
                 <a:cs typeface="Calibri"/>
               </a:rPr>
-              <a:t>be</a:t>
-            </a:r>
-            <a:r>
-              <a:rPr lang="en-US" sz="1800" spc="-1" dirty="0">
-                <a:solidFill>
-                  <a:srgbClr val="003056"/>
-                </a:solidFill>
-                <a:latin typeface="Calibri"/>
-                <a:cs typeface="Calibri"/>
-              </a:rPr>
-              <a:t> </a:t>
-            </a:r>
-            <a:r>
-              <a:rPr lang="en-US" sz="1800" u="sng" spc="-1" dirty="0">
-                <a:solidFill>
-                  <a:srgbClr val="003056"/>
-                </a:solidFill>
-                <a:latin typeface="Arial"/>
-                <a:cs typeface="Arial"/>
-              </a:rPr>
-              <a:t>⋅</a:t>
-            </a:r>
-            <a:r>
-              <a:rPr lang="en-US" sz="1800" u="sng" spc="-1" dirty="0">
-                <a:solidFill>
-                  <a:srgbClr val="003056"/>
-                </a:solidFill>
-                <a:latin typeface="Calibri"/>
-                <a:cs typeface="Calibri"/>
-              </a:rPr>
-              <a:t>neglected</a:t>
-            </a:r>
-            <a:r>
-              <a:rPr lang="en-US" sz="1800" spc="-1" dirty="0">
-                <a:solidFill>
-                  <a:srgbClr val="003056"/>
-                </a:solidFill>
-                <a:latin typeface="Calibri"/>
-                <a:cs typeface="Calibri"/>
-              </a:rPr>
-              <a:t> </a:t>
-            </a:r>
-            <a:r>
-              <a:rPr lang="en-US" sz="1800" u="sng" spc="-1" dirty="0">
-                <a:solidFill>
-                  <a:srgbClr val="003056"/>
-                </a:solidFill>
-                <a:latin typeface="Arial"/>
-                <a:cs typeface="Arial"/>
-              </a:rPr>
-              <a:t>⋅</a:t>
-            </a:r>
-            <a:r>
-              <a:rPr lang="en-US" sz="1800" u="sng" spc="-1" dirty="0">
-                <a:solidFill>
-                  <a:srgbClr val="003056"/>
-                </a:solidFill>
-                <a:latin typeface="Calibri"/>
-                <a:cs typeface="Calibri"/>
-              </a:rPr>
-              <a:t>anymore.</a:t>
-            </a:r>
-            <a:endParaRPr lang="en-US" sz="1800" dirty="0"/>
+              <a:t>⋅anymore.</a:t>
+            </a:r>
+            <a:endParaRPr lang="en-US" sz="1800">
+              <a:latin typeface="Calibri"/>
+              <a:ea typeface="Calibri"/>
+              <a:cs typeface="Calibri"/>
+            </a:endParaRPr>
           </a:p>
           <a:p>
             <a:pPr>
@@ -39007,6 +38958,8 @@
                   <a:srgbClr val="003056"/>
                 </a:solidFill>
                 <a:latin typeface="Calibri"/>
+                <a:ea typeface="Calibri"/>
+                <a:cs typeface="Calibri"/>
               </a:rPr>
               <a:t>Output sequences</a:t>
             </a:r>
@@ -39016,10 +38969,16 @@
                   <a:srgbClr val="003056"/>
                 </a:solidFill>
                 <a:latin typeface="Calibri"/>
+                <a:ea typeface="Calibri"/>
+                <a:cs typeface="Calibri"/>
               </a:rPr>
               <a:t> are composed of set of these known tokens</a:t>
             </a:r>
-            <a:endParaRPr lang="en-US" sz="2000" dirty="0"/>
+            <a:endParaRPr lang="en-US" sz="2000">
+              <a:latin typeface="Calibri"/>
+              <a:ea typeface="Calibri"/>
+              <a:cs typeface="Calibri"/>
+            </a:endParaRPr>
           </a:p>
           <a:p>
             <a:pPr lvl="1">
@@ -39040,15 +38999,19 @@
                 <a:solidFill>
                   <a:srgbClr val="003056"/>
                 </a:solidFill>
-                <a:latin typeface="Arial"/>
+                <a:latin typeface="Calibri"/>
+                <a:ea typeface="Calibri"/>
+                <a:cs typeface="Calibri"/>
               </a:rPr>
               <a:t>Next word distribution assigns probability to each of these tokens</a:t>
             </a:r>
-            <a:endParaRPr lang="en-US" sz="1800" spc="-1" dirty="0">
+            <a:endParaRPr lang="en-US" sz="1800" spc="-1">
               <a:solidFill>
                 <a:srgbClr val="003056"/>
               </a:solidFill>
               <a:latin typeface="Calibri"/>
+              <a:ea typeface="Calibri"/>
+              <a:cs typeface="Calibri"/>
             </a:endParaRPr>
           </a:p>
           <a:p>
@@ -39064,11 +39027,13 @@
               </a:buClr>
               <a:buNone/>
             </a:pPr>
-            <a:endParaRPr lang="en-US" sz="1600" b="1">
+            <a:endParaRPr lang="en-US" sz="1600" b="1" dirty="0">
               <a:solidFill>
                 <a:srgbClr val="003056"/>
               </a:solidFill>
-              <a:latin typeface="Arial"/>
+              <a:latin typeface="Calibri"/>
+              <a:ea typeface="Calibri"/>
+              <a:cs typeface="Calibri"/>
             </a:endParaRPr>
           </a:p>
           <a:p>
@@ -39085,11 +39050,13 @@
               <a:buFont typeface="Arial"/>
               <a:buChar char="•"/>
             </a:pPr>
-            <a:endParaRPr lang="en-US" sz="2000" b="1" spc="-1">
+            <a:endParaRPr lang="en-US" sz="2000" b="1" spc="-1" dirty="0">
               <a:solidFill>
                 <a:srgbClr val="003056"/>
               </a:solidFill>
               <a:latin typeface="Calibri"/>
+              <a:ea typeface="Calibri"/>
+              <a:cs typeface="Calibri"/>
             </a:endParaRPr>
           </a:p>
           <a:p>
@@ -39106,11 +39073,13 @@
               <a:buFont typeface="Arial"/>
               <a:buChar char="•"/>
             </a:pPr>
-            <a:endParaRPr lang="en-US" sz="2000" b="1" spc="-1">
+            <a:endParaRPr lang="en-US" sz="2000" b="1" spc="-1" dirty="0">
               <a:solidFill>
                 <a:srgbClr val="003056"/>
               </a:solidFill>
               <a:latin typeface="Calibri"/>
+              <a:ea typeface="Calibri"/>
+              <a:cs typeface="Calibri"/>
             </a:endParaRPr>
           </a:p>
           <a:p>
@@ -39127,11 +39096,13 @@
               <a:buFont typeface="Arial"/>
               <a:buChar char="•"/>
             </a:pPr>
-            <a:endParaRPr lang="en-US" sz="2000" b="1" spc="-1">
+            <a:endParaRPr lang="en-US" sz="2000" b="1" spc="-1" dirty="0">
               <a:solidFill>
                 <a:srgbClr val="003056"/>
               </a:solidFill>
               <a:latin typeface="Calibri"/>
+              <a:ea typeface="Calibri"/>
+              <a:cs typeface="Calibri"/>
             </a:endParaRPr>
           </a:p>
           <a:p>
@@ -39148,11 +39119,13 @@
               <a:buFont typeface="Arial"/>
               <a:buChar char="•"/>
             </a:pPr>
-            <a:endParaRPr lang="en-US" sz="2000" b="1" spc="-1">
+            <a:endParaRPr lang="en-US" sz="2000" b="1" spc="-1" dirty="0">
               <a:solidFill>
                 <a:srgbClr val="003056"/>
               </a:solidFill>
               <a:latin typeface="Calibri"/>
+              <a:ea typeface="Calibri"/>
+              <a:cs typeface="Calibri"/>
             </a:endParaRPr>
           </a:p>
           <a:p>
@@ -39169,11 +39142,13 @@
               <a:buFont typeface="Arial"/>
               <a:buChar char="•"/>
             </a:pPr>
-            <a:endParaRPr lang="en-US" sz="2200" b="1" spc="-1">
+            <a:endParaRPr lang="en-US" sz="2200" b="1" spc="-1" dirty="0">
               <a:solidFill>
                 <a:srgbClr val="003056"/>
               </a:solidFill>
               <a:latin typeface="Calibri"/>
+              <a:ea typeface="Calibri"/>
+              <a:cs typeface="Calibri"/>
             </a:endParaRPr>
           </a:p>
         </p:txBody>
@@ -39890,7 +39865,7 @@
                 </a:solidFill>
                 <a:latin typeface="Calibri"/>
               </a:rPr>
-              <a:t>Dr. Daniel Ruffinelli - FSS 2025</a:t>
+              <a:t>Dr. Daniel Ruffinelli - FSS 2026</a:t>
             </a:r>
             <a:endParaRPr lang="en-US" sz="1200" b="0" strike="noStrike" spc="-1">
               <a:latin typeface="Times New Roman"/>
@@ -41779,7 +41754,7 @@
                 </a:solidFill>
                 <a:latin typeface="Calibri"/>
               </a:rPr>
-              <a:t>Dr. Daniel Ruffinelli - FSS 2025</a:t>
+              <a:t>Dr. Daniel Ruffinelli - FSS 2026</a:t>
             </a:r>
             <a:endParaRPr lang="en-US" sz="1200" b="0" strike="noStrike" spc="-1">
               <a:latin typeface="Times New Roman"/>

</xml_diff>